<commit_message>
-Se cargan los documentos
</commit_message>
<xml_diff>
--- a/Documento/43.8_presentacion_sprint2_Francisco_Aythami_Nicolás.pptx
+++ b/Documento/43.8_presentacion_sprint2_Francisco_Aythami_Nicolás.pptx
@@ -7881,12 +7881,17 @@
               <a:buChar char="•"/>
             </a:pPr>
             <a:r>
-              <a:rPr lang="es-ES" dirty="0">
-                <a:hlinkClick r:id="rId3"/>
+              <a:rPr lang="es-ES" b="0" i="0" u="sng" dirty="0">
+                <a:effectLst/>
+                <a:latin typeface="inherit"/>
+                <a:hlinkClick r:id="rId3" tooltip="https://github.com/AythamiPV/Reserly/tree/sprint2"/>
               </a:rPr>
-              <a:t>https://github.com/AythamiPV/Reserly</a:t>
-            </a:r>
-            <a:endParaRPr lang="es-ES" dirty="0"/>
+              <a:t>https://github.com/AythamiPV/Reserly/tree/sprint2</a:t>
+            </a:r>
+            <a:endParaRPr lang="es-ES" b="0" i="0" u="sng" dirty="0">
+              <a:effectLst/>
+              <a:latin typeface="inherit"/>
+            </a:endParaRPr>
           </a:p>
           <a:p>
             <a:pPr marL="457200" lvl="1" indent="0">
@@ -7902,15 +7907,6 @@
               <a:buFont typeface="Arial" panose="020B0604020202020204" pitchFamily="34" charset="0"/>
               <a:buChar char="•"/>
             </a:pPr>
-            <a:r>
-              <a:rPr lang="es-ES" dirty="0">
-                <a:solidFill>
-                  <a:schemeClr val="tx1"/>
-                </a:solidFill>
-                <a:latin typeface="Arial" panose="020B0604020202020204" pitchFamily="34" charset="0"/>
-              </a:rPr>
-              <a:t>x</a:t>
-            </a:r>
             <a:endParaRPr lang="es" dirty="0"/>
           </a:p>
           <a:p>
@@ -7973,6 +7969,114 @@
               <a:t>11</a:t>
             </a:fld>
             <a:endParaRPr lang="en-US" dirty="0"/>
+          </a:p>
+        </p:txBody>
+      </p:sp>
+      <p:sp>
+        <p:nvSpPr>
+          <p:cNvPr id="5" name="Rectangle 2">
+            <a:extLst>
+              <a:ext uri="{FF2B5EF4-FFF2-40B4-BE49-F238E27FC236}">
+                <a16:creationId xmlns:a16="http://schemas.microsoft.com/office/drawing/2014/main" id="{4DC89BD4-5A81-4567-7E45-7721CB1A958B}"/>
+              </a:ext>
+            </a:extLst>
+          </p:cNvPr>
+          <p:cNvSpPr>
+            <a:spLocks noChangeArrowheads="1"/>
+          </p:cNvSpPr>
+          <p:nvPr/>
+        </p:nvSpPr>
+        <p:spPr bwMode="auto">
+          <a:xfrm>
+            <a:off x="1435510" y="3510116"/>
+            <a:ext cx="12192000" cy="0"/>
+          </a:xfrm>
+          <a:prstGeom prst="rect">
+            <a:avLst/>
+          </a:prstGeom>
+          <a:noFill/>
+          <a:ln>
+            <a:noFill/>
+          </a:ln>
+          <a:effectLst/>
+          <a:extLst>
+            <a:ext uri="{909E8E84-426E-40DD-AFC4-6F175D3DCCD1}">
+              <a14:hiddenFill xmlns:a14="http://schemas.microsoft.com/office/drawing/2010/main">
+                <a:solidFill>
+                  <a:schemeClr val="accent1"/>
+                </a:solidFill>
+              </a14:hiddenFill>
+            </a:ext>
+            <a:ext uri="{91240B29-F687-4F45-9708-019B960494DF}">
+              <a14:hiddenLine xmlns:a14="http://schemas.microsoft.com/office/drawing/2010/main" w="9525">
+                <a:solidFill>
+                  <a:schemeClr val="tx1"/>
+                </a:solidFill>
+                <a:miter lim="800000"/>
+                <a:headEnd/>
+                <a:tailEnd/>
+              </a14:hiddenLine>
+            </a:ext>
+            <a:ext uri="{AF507438-7753-43E0-B8FC-AC1667EBCBE1}">
+              <a14:hiddenEffects xmlns:a14="http://schemas.microsoft.com/office/drawing/2010/main">
+                <a:effectLst>
+                  <a:outerShdw dist="35921" dir="2700000" algn="ctr" rotWithShape="0">
+                    <a:schemeClr val="bg2"/>
+                  </a:outerShdw>
+                </a:effectLst>
+              </a14:hiddenEffects>
+            </a:ext>
+          </a:extLst>
+        </p:spPr>
+        <p:txBody>
+          <a:bodyPr vert="horz" wrap="square" lIns="91440" tIns="45720" rIns="91440" bIns="45720" numCol="1" anchor="ctr" anchorCtr="0" compatLnSpc="1">
+            <a:prstTxWarp prst="textNoShape">
+              <a:avLst/>
+            </a:prstTxWarp>
+            <a:spAutoFit/>
+          </a:bodyPr>
+          <a:lstStyle/>
+          <a:p>
+            <a:pPr marL="0" marR="0" lvl="0" indent="0" algn="l" defTabSz="914400" rtl="0" eaLnBrk="0" fontAlgn="base" latinLnBrk="0" hangingPunct="0">
+              <a:lnSpc>
+                <a:spcPct val="100000"/>
+              </a:lnSpc>
+              <a:spcBef>
+                <a:spcPct val="0"/>
+              </a:spcBef>
+              <a:spcAft>
+                <a:spcPct val="0"/>
+              </a:spcAft>
+              <a:buClrTx/>
+              <a:buSzTx/>
+              <a:buFontTx/>
+              <a:buNone/>
+              <a:tabLst/>
+            </a:pPr>
+            <a:r>
+              <a:rPr kumimoji="0" lang="es-ES" altLang="es-ES" sz="1800" b="0" i="0" u="none" strike="noStrike" cap="none" normalizeH="0" baseline="0" dirty="0">
+                <a:ln>
+                  <a:noFill/>
+                </a:ln>
+                <a:solidFill>
+                  <a:schemeClr val="tx1"/>
+                </a:solidFill>
+                <a:effectLst/>
+                <a:latin typeface="Arial" panose="020B0604020202020204" pitchFamily="34" charset="0"/>
+                <a:hlinkClick r:id="rId5"/>
+              </a:rPr>
+              <a:t>43.8_Video_sprint2_Francisco_Aythami_Nicolas.mp4</a:t>
+            </a:r>
+            <a:endParaRPr kumimoji="0" lang="es-ES" altLang="es-ES" sz="1800" b="0" i="0" u="none" strike="noStrike" cap="none" normalizeH="0" baseline="0" dirty="0">
+              <a:ln>
+                <a:noFill/>
+              </a:ln>
+              <a:solidFill>
+                <a:schemeClr val="tx1"/>
+              </a:solidFill>
+              <a:effectLst/>
+              <a:latin typeface="Arial" panose="020B0604020202020204" pitchFamily="34" charset="0"/>
+            </a:endParaRPr>
           </a:p>
         </p:txBody>
       </p:sp>
@@ -11473,6 +11577,26 @@
 </file>
 
 <file path=customXml/item1.xml><?xml version="1.0" encoding="utf-8"?>
+<p:properties xmlns:p="http://schemas.microsoft.com/office/2006/metadata/properties" xmlns:xsi="http://www.w3.org/2001/XMLSchema-instance" xmlns:pc="http://schemas.microsoft.com/office/infopath/2007/PartnerControls">
+  <documentManagement>
+    <MediaServiceKeyPoints xmlns="71af3243-3dd4-4a8d-8c0d-dd76da1f02a5" xsi:nil="true"/>
+    <_ip_UnifiedCompliancePolicyUIAction xmlns="http://schemas.microsoft.com/sharepoint/v3" xsi:nil="true"/>
+    <Image xmlns="71af3243-3dd4-4a8d-8c0d-dd76da1f02a5">
+      <Url xsi:nil="true"/>
+      <Description xsi:nil="true"/>
+    </Image>
+    <Status xmlns="71af3243-3dd4-4a8d-8c0d-dd76da1f02a5">Not started</Status>
+    <Background xmlns="71af3243-3dd4-4a8d-8c0d-dd76da1f02a5">false</Background>
+    <_ip_UnifiedCompliancePolicyProperties xmlns="http://schemas.microsoft.com/sharepoint/v3" xsi:nil="true"/>
+    <ImageTagsTaxHTField xmlns="71af3243-3dd4-4a8d-8c0d-dd76da1f02a5">
+      <Terms xmlns="http://schemas.microsoft.com/office/infopath/2007/PartnerControls"/>
+    </ImageTagsTaxHTField>
+    <TaxCatchAll xmlns="230e9df3-be65-4c73-a93b-d1236ebd677e" xsi:nil="true"/>
+  </documentManagement>
+</p:properties>
+</file>
+
+<file path=customXml/item2.xml><?xml version="1.0" encoding="utf-8"?>
 <ct:contentTypeSchema xmlns:ct="http://schemas.microsoft.com/office/2006/metadata/contentType" xmlns:ma="http://schemas.microsoft.com/office/2006/metadata/properties/metaAttributes" ct:_="" ma:_="" ma:contentTypeName="Document" ma:contentTypeID="0x01010079F111ED35F8CC479449609E8A0923A6" ma:contentTypeVersion="29" ma:contentTypeDescription="Create a new document." ma:contentTypeScope="" ma:versionID="6a914531ae0f23be31da2eba1f3b42a9">
   <xsd:schema xmlns:xsd="http://www.w3.org/2001/XMLSchema" xmlns:xs="http://www.w3.org/2001/XMLSchema" xmlns:p="http://schemas.microsoft.com/office/2006/metadata/properties" xmlns:ns1="http://schemas.microsoft.com/sharepoint/v3" xmlns:ns2="71af3243-3dd4-4a8d-8c0d-dd76da1f02a5" xmlns:ns3="16c05727-aa75-4e4a-9b5f-8a80a1165891" xmlns:ns4="230e9df3-be65-4c73-a93b-d1236ebd677e" targetNamespace="http://schemas.microsoft.com/office/2006/metadata/properties" ma:root="true" ma:fieldsID="ae00154c9e66547f022c4923f88826d6" ns1:_="" ns2:_="" ns3:_="" ns4:_="">
     <xsd:import namespace="http://schemas.microsoft.com/sharepoint/v3"/>
@@ -11784,26 +11908,6 @@
 </ct:contentTypeSchema>
 </file>
 
-<file path=customXml/item2.xml><?xml version="1.0" encoding="utf-8"?>
-<p:properties xmlns:p="http://schemas.microsoft.com/office/2006/metadata/properties" xmlns:xsi="http://www.w3.org/2001/XMLSchema-instance" xmlns:pc="http://schemas.microsoft.com/office/infopath/2007/PartnerControls">
-  <documentManagement>
-    <MediaServiceKeyPoints xmlns="71af3243-3dd4-4a8d-8c0d-dd76da1f02a5" xsi:nil="true"/>
-    <_ip_UnifiedCompliancePolicyUIAction xmlns="http://schemas.microsoft.com/sharepoint/v3" xsi:nil="true"/>
-    <Image xmlns="71af3243-3dd4-4a8d-8c0d-dd76da1f02a5">
-      <Url xsi:nil="true"/>
-      <Description xsi:nil="true"/>
-    </Image>
-    <Status xmlns="71af3243-3dd4-4a8d-8c0d-dd76da1f02a5">Not started</Status>
-    <Background xmlns="71af3243-3dd4-4a8d-8c0d-dd76da1f02a5">false</Background>
-    <_ip_UnifiedCompliancePolicyProperties xmlns="http://schemas.microsoft.com/sharepoint/v3" xsi:nil="true"/>
-    <ImageTagsTaxHTField xmlns="71af3243-3dd4-4a8d-8c0d-dd76da1f02a5">
-      <Terms xmlns="http://schemas.microsoft.com/office/infopath/2007/PartnerControls"/>
-    </ImageTagsTaxHTField>
-    <TaxCatchAll xmlns="230e9df3-be65-4c73-a93b-d1236ebd677e" xsi:nil="true"/>
-  </documentManagement>
-</p:properties>
-</file>
-
 <file path=customXml/item3.xml><?xml version="1.0" encoding="utf-8"?>
 <?mso-contentType ?>
 <FormTemplates xmlns="http://schemas.microsoft.com/sharepoint/v3/contenttype/forms">
@@ -11814,6 +11918,25 @@
 </file>
 
 <file path=customXml/itemProps1.xml><?xml version="1.0" encoding="utf-8"?>
+<ds:datastoreItem xmlns:ds="http://schemas.openxmlformats.org/officeDocument/2006/customXml" ds:itemID="{7B247F30-5811-40C0-99EC-CF53200590BE}">
+  <ds:schemaRefs>
+    <ds:schemaRef ds:uri="http://schemas.microsoft.com/sharepoint/v3"/>
+    <ds:schemaRef ds:uri="16c05727-aa75-4e4a-9b5f-8a80a1165891"/>
+    <ds:schemaRef ds:uri="http://schemas.microsoft.com/office/2006/metadata/properties"/>
+    <ds:schemaRef ds:uri="71af3243-3dd4-4a8d-8c0d-dd76da1f02a5"/>
+    <ds:schemaRef ds:uri="http://schemas.microsoft.com/office/2006/documentManagement/types"/>
+    <ds:schemaRef ds:uri="http://purl.org/dc/dcmitype/"/>
+    <ds:schemaRef ds:uri="http://schemas.openxmlformats.org/package/2006/metadata/core-properties"/>
+    <ds:schemaRef ds:uri="http://purl.org/dc/terms/"/>
+    <ds:schemaRef ds:uri="http://www.w3.org/XML/1998/namespace"/>
+    <ds:schemaRef ds:uri="230e9df3-be65-4c73-a93b-d1236ebd677e"/>
+    <ds:schemaRef ds:uri="http://schemas.microsoft.com/office/infopath/2007/PartnerControls"/>
+    <ds:schemaRef ds:uri="http://purl.org/dc/elements/1.1/"/>
+  </ds:schemaRefs>
+</ds:datastoreItem>
+</file>
+
+<file path=customXml/itemProps2.xml><?xml version="1.0" encoding="utf-8"?>
 <ds:datastoreItem xmlns:ds="http://schemas.openxmlformats.org/officeDocument/2006/customXml" ds:itemID="{A8837B91-4329-4308-94DA-BB811B5F3092}">
   <ds:schemaRefs>
     <ds:schemaRef ds:uri="http://schemas.microsoft.com/office/2006/metadata/contentType"/>
@@ -11834,25 +11957,6 @@
 </ds:datastoreItem>
 </file>
 
-<file path=customXml/itemProps2.xml><?xml version="1.0" encoding="utf-8"?>
-<ds:datastoreItem xmlns:ds="http://schemas.openxmlformats.org/officeDocument/2006/customXml" ds:itemID="{7B247F30-5811-40C0-99EC-CF53200590BE}">
-  <ds:schemaRefs>
-    <ds:schemaRef ds:uri="http://schemas.microsoft.com/office/2006/documentManagement/types"/>
-    <ds:schemaRef ds:uri="http://purl.org/dc/elements/1.1/"/>
-    <ds:schemaRef ds:uri="http://schemas.microsoft.com/sharepoint/v3"/>
-    <ds:schemaRef ds:uri="http://schemas.microsoft.com/office/infopath/2007/PartnerControls"/>
-    <ds:schemaRef ds:uri="http://www.w3.org/XML/1998/namespace"/>
-    <ds:schemaRef ds:uri="http://purl.org/dc/terms/"/>
-    <ds:schemaRef ds:uri="http://schemas.microsoft.com/office/2006/metadata/properties"/>
-    <ds:schemaRef ds:uri="71af3243-3dd4-4a8d-8c0d-dd76da1f02a5"/>
-    <ds:schemaRef ds:uri="http://schemas.openxmlformats.org/package/2006/metadata/core-properties"/>
-    <ds:schemaRef ds:uri="230e9df3-be65-4c73-a93b-d1236ebd677e"/>
-    <ds:schemaRef ds:uri="16c05727-aa75-4e4a-9b5f-8a80a1165891"/>
-    <ds:schemaRef ds:uri="http://purl.org/dc/dcmitype/"/>
-  </ds:schemaRefs>
-</ds:datastoreItem>
-</file>
-
 <file path=customXml/itemProps3.xml><?xml version="1.0" encoding="utf-8"?>
 <ds:datastoreItem xmlns:ds="http://schemas.openxmlformats.org/officeDocument/2006/customXml" ds:itemID="{55E72E99-0076-433E-AD3A-575A11FAB73D}">
   <ds:schemaRefs>

</xml_diff>